<commit_message>
fix: deck video link
</commit_message>
<xml_diff>
--- a/docs/SRM_floppydisk_Submission.pptx
+++ b/docs/SRM_floppydisk_Submission.pptx
@@ -14250,7 +14250,16 @@
                 </a:solidFill>
                 <a:latin typeface="Montserrat"/>
               </a:rPr>
-              <a:t>    github.com/wtfPrethiv/seraph</a:t>
+              <a:t>    </a:t>
+            </a:r>
+            <a:r>
+              <a:rPr sz="1200" b="0">
+                <a:solidFill>
+                  <a:srgbClr val="63637E"/>
+                </a:solidFill>
+                <a:latin typeface="Montserrat"/>
+              </a:rPr>
+              <a:t>github.com/wtfPrethiv/seraph</a:t>
             </a:r>
           </a:p>
         </p:txBody>
@@ -14371,7 +14380,16 @@
                 </a:solidFill>
                 <a:latin typeface="Montserrat"/>
               </a:rPr>
-              <a:t>    Results, setup, CLI, MCP and Morpheus sections</a:t>
+              <a:t>    </a:t>
+            </a:r>
+            <a:r>
+              <a:rPr sz="1200" b="0">
+                <a:solidFill>
+                  <a:srgbClr val="63637E"/>
+                </a:solidFill>
+                <a:latin typeface="Montserrat"/>
+              </a:rPr>
+              <a:t>Results, setup, CLI, MCP and Morpheus sections</a:t>
             </a:r>
           </a:p>
         </p:txBody>
@@ -14492,7 +14510,17 @@
                 </a:solidFill>
                 <a:latin typeface="Montserrat"/>
               </a:rPr>
-              <a:t>    Google Drive: drive.google.com/drive/…</a:t>
+              <a:t>    </a:t>
+            </a:r>
+            <a:r>
+              <a:rPr sz="1200" b="0">
+                <a:solidFill>
+                  <a:srgbClr val="3B5BDB"/>
+                </a:solidFill>
+                <a:latin typeface="Montserrat"/>
+                <a:hlinkClick r:id="rId5"/>
+              </a:rPr>
+              <a:t>drive.google.com/drive/folders/1TbShN44FSyemdtEXjca11KWpaW50liuU</a:t>
             </a:r>
           </a:p>
         </p:txBody>
@@ -14613,7 +14641,16 @@
                 </a:solidFill>
                 <a:latin typeface="Montserrat"/>
               </a:rPr>
-              <a:t>    This deck</a:t>
+              <a:t>    </a:t>
+            </a:r>
+            <a:r>
+              <a:rPr sz="1200" b="0">
+                <a:solidFill>
+                  <a:srgbClr val="63637E"/>
+                </a:solidFill>
+                <a:latin typeface="Montserrat"/>
+              </a:rPr>
+              <a:t>This deck</a:t>
             </a:r>
           </a:p>
         </p:txBody>
@@ -14734,7 +14771,16 @@
                 </a:solidFill>
                 <a:latin typeface="Montserrat"/>
               </a:rPr>
-              <a:t>    tag PRISM_GENAI_HACKATHON_Y2026</a:t>
+              <a:t>    </a:t>
+            </a:r>
+            <a:r>
+              <a:rPr sz="1200" b="0">
+                <a:solidFill>
+                  <a:srgbClr val="63637E"/>
+                </a:solidFill>
+                <a:latin typeface="Montserrat"/>
+              </a:rPr>
+              <a:t>tag PRISM_GENAI_HACKATHON_Y2026</a:t>
             </a:r>
           </a:p>
         </p:txBody>
@@ -14855,7 +14901,16 @@
                 </a:solidFill>
                 <a:latin typeface="Montserrat"/>
               </a:rPr>
-              <a:t>    docs/ in the repo</a:t>
+              <a:t>    </a:t>
+            </a:r>
+            <a:r>
+              <a:rPr sz="1200" b="0">
+                <a:solidFill>
+                  <a:srgbClr val="63637E"/>
+                </a:solidFill>
+                <a:latin typeface="Montserrat"/>
+              </a:rPr>
+              <a:t>docs/ in the repo</a:t>
             </a:r>
           </a:p>
         </p:txBody>
@@ -18945,6 +19000,7 @@
                   <a:srgbClr val="3B5BDB"/>
                 </a:solidFill>
                 <a:latin typeface="Montserrat"/>
+                <a:hlinkClick r:id="rId5"/>
               </a:rPr>
               <a:t>drive.google.com/drive/folders/1TbShN44FSyemdtEXjca11KWpaW50liuU</a:t>
             </a:r>

</xml_diff>

<commit_message>
fix: deck cpu numbers
</commit_message>
<xml_diff>
--- a/docs/SRM_floppydisk_Submission.pptx
+++ b/docs/SRM_floppydisk_Submission.pptx
@@ -20073,7 +20073,7 @@
                 </a:solidFill>
                 <a:latin typeface="Montserrat"/>
               </a:rPr>
-              <a:t>A new commit re-indexes only changed files: 3 files, 186 ms on the Morpheus repo.</a:t>
+              <a:t>Django: 2,899 files indexed in 31 s; the next release re-indexes in 1.3 s, reading only 38 changed files.</a:t>
             </a:r>
           </a:p>
         </p:txBody>
@@ -20134,7 +20134,7 @@
                 </a:solidFill>
                 <a:latin typeface="Montserrat"/>
               </a:rPr>
-              <a:t>Privacy and cost</a:t>
+              <a:t>Runs on a laptop CPU</a:t>
             </a:r>
           </a:p>
           <a:p>
@@ -20146,7 +20146,7 @@
                 </a:solidFill>
                 <a:latin typeface="Montserrat"/>
               </a:rPr>
-              <a:t>Embedding, ranking and indexing run on the developer's machine, with no API calls.</a:t>
+              <a:t>No API calls. CPU only: about 0.9 s per new question with BGE-Code-v1, 0.15 s with EmbeddingGemma-300M; precomputed vectors skip the corpus build.</a:t>
             </a:r>
           </a:p>
         </p:txBody>
@@ -21797,7 +21797,7 @@
                 </a:solidFill>
                 <a:latin typeface="Montserrat"/>
               </a:rPr>
-              <a:t>Faster CPU mode</a:t>
+              <a:t>Agent benchmark</a:t>
             </a:r>
           </a:p>
           <a:p>
@@ -21809,7 +21809,7 @@
                 </a:solidFill>
                 <a:latin typeface="Montserrat"/>
               </a:rPr>
-              <a:t>A smaller embedder such as EmbeddingGemma-300M for laptops without a GPU, plus measured CPU timings.</a:t>
+              <a:t>Measure how many tool calls and tokens Morpheus saves with Seraph compared with grep on real coding tasks.</a:t>
             </a:r>
           </a:p>
         </p:txBody>

</xml_diff>